<commit_message>
docs: deck and script review fixes (refs #37)
- Slide 5: building owners add "other flexible loads", not heat pumps,
  which PeakPilot does not model.
- Slide 6: tasks "traced to requirements" (50 of 51 link one); the hooks
  card names all five hooks.
- Hidden slide 14: Hypothesis covers Python and proptest covers Rust,
  not "both engines".
- Script: slide 6 gets 20 s with narration naming each card; timestamps
  shift to a 2:42 total.

Co-Authored-By: Claude Opus 5.5 <noreply@anthropic.com>
</commit_message>
<xml_diff>
--- a/docs/PeakPilot_deck.pptx
+++ b/docs/PeakPilot_deck.pptx
@@ -3007,7 +3007,7 @@
           <a:p>
             <a:r>
               <a:rPr lang="en-US" dirty="0"/>
-              <a:t>PeakPilot was built spec-first in Kiro. Four Kiro specs cover the engine, the Rust port, the LP benchmark and the test framework, and every task traces to a requirement. Four steering docs carry the honesty rules into every edit. Five hooks guard destructive commands, remind the agent to check library docs, validate diagrams and clean up merged worktrees. Through MCP, Kiro checked the live dashboard in a real browser and ran the GitHub issues and pull requests. Rust property tests found two real bugs. Later specs were written with Claude Code in Kiro's format, and the repo says so.</a:t>
+              <a:t>PeakPilot was built spec-first in Kiro. Four Kiro specs cover the engine, the Rust port, the LP benchmark and the test framework, and their tasks trace to requirements. Four steering docs carry the honesty rules into every edit. Five hooks guard destructive commands, remind the agent to check library docs, enforce Mermaid layout, suggest diagrams where they help, and clean up merged worktrees. Through MCP, Kiro checked the live dashboard in a real browser and ran the GitHub issues and pull requests. Rust property tests found two real bugs. Later specs were written with Claude Code in Kiro's format, and the repo says so.</a:t>
             </a:r>
             <a:endParaRPr lang="en-US" dirty="0"/>
           </a:p>
@@ -3095,7 +3095,7 @@
           <a:p>
             <a:r>
               <a:rPr lang="en-US" dirty="0"/>
-              <a:t>Who benefits: building owners who need to add EV chargers and heat pumps without blowing through their power limit; utilities, who get flexible load moved out of the evening peak and reported honestly; and Massachusetts towns, with 351 towns mapped to their utility. It is free, open source and runs offline. It scales by swapping simulated devices for real ones behind the same interface, with the Rust controller on a Raspberry Pi in each building. Today the simulation, CI and Pi image build work; real devices and a physical Pi are next.</a:t>
+              <a:t>Who benefits: building owners who need to add EV chargers and other flexible loads without blowing through their power limit; utilities, who get flexible load moved out of the evening peak and reported honestly; and Massachusetts towns, with 351 towns mapped to their utility. It is free, open source and runs offline. It scales by swapping simulated devices for real ones behind the same interface, with the Rust controller on a Raspberry Pi in each building. Today the simulation, CI and Pi image build work; real devices and a physical Pi are next.</a:t>
             </a:r>
             <a:endParaRPr lang="en-US" dirty="0"/>
           </a:p>
@@ -6251,7 +6251,7 @@
                   <a:schemeClr val="tx1"/>
                 </a:solidFill>
               </a:rPr>
-              <a:t>180 pytest tests with a 90% coverage gate in CI, plus Hypothesis and Rust property tests across both engines.</a:t>
+              <a:t>180 pytest tests with a 90% coverage gate in CI, plus Hypothesis property tests in Python and proptest in Rust.</a:t>
             </a:r>
             <a:endParaRPr lang="en-US" sz="1500" dirty="0"/>
           </a:p>
@@ -7241,7 +7241,7 @@
                   <a:schemeClr val="tx1"/>
                 </a:solidFill>
               </a:rPr>
-              <a:t xml:space="preserve">4 Kiro specs (engine, Rust port, LP benchmark, tests): requirements → design → tasks, each task traced to a requirement.</a:t>
+              <a:t xml:space="preserve">4 Kiro specs (engine, Rust port, LP benchmark, tests): requirements → design → tasks, with tasks traced to requirements.</a:t>
             </a:r>
             <a:endParaRPr lang="en-US" sz="1400" dirty="0"/>
           </a:p>
@@ -7563,7 +7563,7 @@
                   <a:schemeClr val="tx1"/>
                 </a:solidFill>
               </a:rPr>
-              <a:t xml:space="preserve">5 hooks: ask before destructive commands, Context7 docs reminder, Mermaid validation, clean up merged worktrees.</a:t>
+              <a:t xml:space="preserve">5 hooks: command guard, Context7 docs reminder, Mermaid layout check, diagram suggestions, worktree cleanup.</a:t>
             </a:r>
             <a:endParaRPr lang="en-US" sz="1400" dirty="0"/>
           </a:p>
@@ -8354,7 +8354,7 @@
                   <a:schemeClr val="tx1"/>
                 </a:solidFill>
               </a:rPr>
-              <a:t xml:space="preserve">Add EV chargers and heat pumps under the power limit they already have, with every deadline met and every decision in plain language.</a:t>
+              <a:t xml:space="preserve">Add EV chargers and other flexible loads under their existing power limit, with every deadline met and every decision explained.</a:t>
             </a:r>
             <a:endParaRPr lang="en-US" sz="1400" dirty="0"/>
           </a:p>

</xml_diff>

<commit_message>
docs: say how Kiro IDE, CLI and Crew differed (refs #37)
Slide 6's tools card and the form's Tools note now give each tool its own
job, confirmed from the local Kiro session logs: the IDE wrote specs and
code, the CLI ran the chrome-devtools design review behind PR #14, and
Crew worked alongside (merged PR #12, cleaned up branches). The Tools
[confirm] marker is resolved.

Co-Authored-By: Claude Opus 5.5 <noreply@anthropic.com>
</commit_message>
<xml_diff>
--- a/docs/PeakPilot_deck.pptx
+++ b/docs/PeakPilot_deck.pptx
@@ -3007,7 +3007,7 @@
           <a:p>
             <a:r>
               <a:rPr lang="en-US" dirty="0"/>
-              <a:t>PeakPilot was built spec-first in Kiro. Four Kiro specs cover the engine, the Rust port, the LP benchmark and the test framework, and their tasks trace to requirements. Four steering docs carry the honesty rules into every edit. Five hooks guard destructive commands, remind the agent to check library docs, enforce Mermaid layout, suggest diagrams where they help, and clean up merged worktrees. Through MCP, Kiro checked the live dashboard in a real browser and ran the GitHub issues and pull requests. Rust property tests found two real bugs. Later specs were written with Claude Code in Kiro's format, and the repo says so.</a:t>
+              <a:t>PeakPilot was built spec-first in Kiro. Four Kiro specs cover the engine, the Rust port, the LP benchmark and the test framework, and their tasks trace to requirements. Four steering docs carry the honesty rules into every edit. Five hooks guard destructive commands, remind the agent to check library docs, enforce Mermaid layout, suggest diagrams where they help, and clean up merged worktrees. Through MCP, Kiro checked the live dashboard in a real browser and ran the GitHub issues and pull requests. Rust property tests found two real bugs. Each Kiro tool had its own job: the IDE wrote the specs and code, the CLI ran a browser design review that led to PR #14, and Crew worked alongside, merging PR #12 and cleaning up branches. Later specs were written with Claude Code in Kiro's format, and the repo says so.</a:t>
             </a:r>
             <a:endParaRPr lang="en-US" dirty="0"/>
           </a:p>
@@ -8046,7 +8046,7 @@
                   <a:schemeClr val="tx1"/>
                 </a:solidFill>
               </a:rPr>
-              <a:t xml:space="preserve">Kiro IDE for specs, code and hooks; Kiro CLI and Crew agents on the same repo and steering for merges and runs.</a:t>
+              <a:t xml:space="preserve">IDE: specs and code. CLI: browser design review → PR #14. Crew: in parallel, merged PR #12 and cleaned up branches.</a:t>
             </a:r>
             <a:endParaRPr lang="en-US" sz="1400" dirty="0"/>
           </a:p>

</xml_diff>

<commit_message>
docs: align slide 6 tools card with the Kiro account on main (refs #37)
#40 records the surfaces as the Kiro IDE plus one Kiro CLI session, with
PR #12 merged by the IDE's multi-agent workflow. The previous card wrongly
credited Kiro Crew with merging PR #12. The card is now "IDE, CLI, Powers":
IDE specs, code and the PR #12 workflow; the CLI UI review behind PR #14;
the Context7 Power for API docs. Speaker notes match.

Co-Authored-By: Claude Opus 5.5 <noreply@anthropic.com>
</commit_message>
<xml_diff>
--- a/docs/PeakPilot_deck.pptx
+++ b/docs/PeakPilot_deck.pptx
@@ -3007,7 +3007,7 @@
           <a:p>
             <a:r>
               <a:rPr lang="en-US" dirty="0"/>
-              <a:t>PeakPilot was built spec-first in Kiro. Four Kiro specs cover the engine, the Rust port, the LP benchmark and the test framework, and their tasks trace to requirements. Four steering docs carry the honesty rules into every edit. Five hooks guard destructive commands, remind the agent to check library docs, enforce Mermaid layout, suggest diagrams where they help, and clean up merged worktrees. Through MCP, Kiro checked the live dashboard in a real browser and ran the GitHub issues and pull requests. Rust property tests found two real bugs. Each Kiro tool had its own job: the IDE wrote the specs and code, the CLI ran a browser design review that led to PR #14, and Crew worked alongside, merging PR #12 and cleaning up branches. Later specs were written with Claude Code in Kiro's format, and the repo says so.</a:t>
+              <a:t>PeakPilot was built spec-first in Kiro. Four Kiro specs cover the engine, the Rust port, the LP benchmark and the test framework, and their tasks trace to requirements. Four steering docs carry the honesty rules into every edit. Five hooks guard destructive commands, remind the agent to check library docs, enforce Mermaid layout, suggest diagrams where they help, and clean up merged worktrees. Through MCP, Kiro checked the live dashboard in a real browser and ran the GitHub issues and pull requests. Rust property tests found two real bugs. Most of the build ran in the Kiro IDE, including a multi-agent workflow that built the optimal benchmark end to end and merged PR #12. One Kiro CLI session reviewed the dashboard UI and led to PR #14. The Context7 Power checked current Streamlit APIs. Later specs were written with Claude Code in Kiro's format, and the repo says so.</a:t>
             </a:r>
             <a:endParaRPr lang="en-US" dirty="0"/>
           </a:p>
@@ -7893,7 +7893,7 @@
       </p:sp>
       <p:sp>
         <p:nvSpPr>
-          <p:cNvPr id="126" name="IDE, CLI and Crew card"/>
+          <p:cNvPr id="126" name="IDE, CLI, Powers card"/>
           <p:cNvSpPr/>
           <p:nvPr/>
         </p:nvSpPr>
@@ -7927,7 +7927,7 @@
       </p:sp>
       <p:sp>
         <p:nvSpPr>
-          <p:cNvPr id="127" name="IDE, CLI and Crew circle"/>
+          <p:cNvPr id="127" name="IDE, CLI, Powers circle"/>
           <p:cNvSpPr/>
           <p:nvPr/>
         </p:nvSpPr>
@@ -7952,7 +7952,7 @@
       </p:sp>
       <p:pic>
         <p:nvPicPr>
-          <p:cNvPr id="128" name="IDE, CLI and Crew icon" descr="IDE, CLI and Crew">    </p:cNvPr>
+          <p:cNvPr id="128" name="IDE, CLI, Powers icon" descr="IDE, CLI, Powers">    </p:cNvPr>
           <p:cNvPicPr>
             <a:picLocks noChangeAspect="1"/>
           </p:cNvPicPr>
@@ -8007,7 +8007,7 @@
                   <a:schemeClr val="tx2"/>
                 </a:solidFill>
               </a:rPr>
-              <a:t xml:space="preserve">IDE, CLI and Crew</a:t>
+              <a:t xml:space="preserve">IDE, CLI, Powers</a:t>
             </a:r>
             <a:endParaRPr lang="en-US" sz="1800" dirty="0"/>
           </a:p>
@@ -8046,7 +8046,7 @@
                   <a:schemeClr val="tx1"/>
                 </a:solidFill>
               </a:rPr>
-              <a:t xml:space="preserve">IDE: specs and code. CLI: browser design review → PR #14. Crew: in parallel, merged PR #12 and cleaned up branches.</a:t>
+              <a:t xml:space="preserve">IDE: specs, code and a multi-agent workflow that shipped PR #12. CLI: UI review → PR #14. Context7 Power for API docs.</a:t>
             </a:r>
             <a:endParaRPr lang="en-US" sz="1400" dirty="0"/>
           </a:p>

</xml_diff>